<commit_message>
Basket4Ballers : champ lexical, requêtes et insight 02 alignés sur le catalogue
Co-Authored-By: Claude Opus 5.5 <noreply@anthropic.com>
Claude-Session: https://claude.ai/code/session_01BmxtdWjbeRUyPx9e1qVLbT
</commit_message>
<xml_diff>
--- a/rapports/septembre/Basket4Ballers_sept2026.pptx
+++ b/rapports/septembre/Basket4Ballers_sept2026.pptx
@@ -5283,22 +5283,22 @@
               </a:spcAft>
             </a:pPr>
             <a:r>
+              <a:rPr sz="2000" b="1" i="0">
+                <a:solidFill>
+                  <a:srgbClr val="EE6A2C"/>
+                </a:solidFill>
+                <a:latin typeface="Arial"/>
+              </a:rPr>
+              <a:t>Jordan</a:t>
+            </a:r>
+            <a:r>
               <a:rPr sz="1800" b="1" i="0">
                 <a:solidFill>
-                  <a:srgbClr val="EE6A2C"/>
-                </a:solidFill>
-                <a:latin typeface="Arial"/>
-              </a:rPr>
-              <a:t>sneakers blanches</a:t>
-            </a:r>
-            <a:r>
-              <a:rPr sz="1600" b="1" i="0">
-                <a:solidFill>
                   <a:srgbClr val="111111"/>
                 </a:solidFill>
                 <a:latin typeface="Arial"/>
               </a:rPr>
-              <a:t>   jean</a:t>
+              <a:t>   Nike</a:t>
             </a:r>
           </a:p>
           <a:p>
@@ -5314,7 +5314,7 @@
                 </a:solidFill>
                 <a:latin typeface="Arial"/>
               </a:rPr>
-              <a:t>Air Force 1</a:t>
+              <a:t>genouillères</a:t>
             </a:r>
             <a:r>
               <a:rPr sz="1400" b="1" i="0">
@@ -5323,7 +5323,7 @@
                 </a:solidFill>
                 <a:latin typeface="Arial"/>
               </a:rPr>
-              <a:t>   Air Max 90</a:t>
+              <a:t>   ballon de basket</a:t>
             </a:r>
           </a:p>
           <a:p>
@@ -5339,7 +5339,7 @@
                 </a:solidFill>
                 <a:latin typeface="Arial"/>
               </a:rPr>
-              <a:t>New Balance 574</a:t>
+              <a:t>maillots NBA</a:t>
             </a:r>
             <a:r>
               <a:rPr sz="1200" b="0" i="0">
@@ -5348,7 +5348,7 @@
                 </a:solidFill>
                 <a:latin typeface="Arial"/>
               </a:rPr>
-              <a:t>   Cortez</a:t>
+              <a:t>   survêtements</a:t>
             </a:r>
           </a:p>
           <a:p>
@@ -5364,7 +5364,7 @@
                 </a:solidFill>
                 <a:latin typeface="Arial"/>
               </a:rPr>
-              <a:t>marcher toute la journée</a:t>
+              <a:t>Air Force 1</a:t>
             </a:r>
             <a:r>
               <a:rPr sz="1100" b="1" i="0">
@@ -5373,7 +5373,7 @@
                 </a:solidFill>
                 <a:latin typeface="Arial"/>
               </a:rPr>
-              <a:t>   confort</a:t>
+              <a:t>   short de compression</a:t>
             </a:r>
           </a:p>
           <a:p>
@@ -5389,7 +5389,7 @@
                 </a:solidFill>
                 <a:latin typeface="Arial"/>
               </a:rPr>
-              <a:t>Nike P-6000</a:t>
+              <a:t>Équipe de France</a:t>
             </a:r>
             <a:r>
               <a:rPr sz="1100" b="0" i="0">
@@ -5398,7 +5398,7 @@
                 </a:solidFill>
                 <a:latin typeface="Arial"/>
               </a:rPr>
-              <a:t>   running</a:t>
+              <a:t>   Paris Basketball</a:t>
             </a:r>
             <a:r>
               <a:rPr sz="1100" b="1" i="0">
@@ -5407,7 +5407,7 @@
                 </a:solidFill>
                 <a:latin typeface="Arial"/>
               </a:rPr>
-              <a:t>   pas chères</a:t>
+              <a:t>   McDavid</a:t>
             </a:r>
           </a:p>
           <a:p>
@@ -5423,7 +5423,7 @@
                 </a:solidFill>
                 <a:latin typeface="Arial"/>
               </a:rPr>
-              <a:t>Wilson Authentic</a:t>
+              <a:t>enfant</a:t>
             </a:r>
             <a:r>
               <a:rPr sz="1100" b="0" i="0">
@@ -5432,7 +5432,7 @@
                 </a:solidFill>
                 <a:latin typeface="Arial"/>
               </a:rPr>
-              <a:t>   ballon de basket</a:t>
+              <a:t>   sneakers</a:t>
             </a:r>
           </a:p>
         </p:txBody>
@@ -5616,7 +5616,7 @@
                 </a:solidFill>
                 <a:latin typeface="Arial"/>
               </a:rPr>
-              <a:t>Des idées de sneakers blanches qui vont bien avec ce jean</a:t>
+              <a:t>Je peux utiliser le Wilson Authentic en salle sans l'abîmer ?</a:t>
             </a:r>
           </a:p>
         </p:txBody>
@@ -5730,7 +5730,7 @@
                 </a:solidFill>
                 <a:latin typeface="Arial"/>
               </a:rPr>
-              <a:t>Montre-moi des baskets solides et pas chères pour marcher beaucoup</a:t>
+              <a:t>Des idées de sneakers blanches qui vont bien avec ce jean</a:t>
             </a:r>
           </a:p>
         </p:txBody>
@@ -5844,52 +5844,43 @@
                 </a:solidFill>
                 <a:latin typeface="Arial"/>
               </a:rPr>
-              <a:t>Je peux porter la P-6000 pour courir régulièrement ?</a:t>
-            </a:r>
-          </a:p>
-        </p:txBody>
-      </p:sp>
-      <p:sp>
-        <p:nvSpPr>
-          <p:cNvPr id="71" name="Rectangle 70"/>
-          <p:cNvSpPr/>
-          <p:nvPr/>
-        </p:nvSpPr>
-        <p:spPr>
-          <a:xfrm>
-            <a:off x="4437888" y="5364480"/>
-            <a:ext cx="2913888" cy="304800"/>
-          </a:xfrm>
-          <a:prstGeom prst="rect">
-            <a:avLst/>
-          </a:prstGeom>
-          <a:solidFill>
-            <a:srgbClr val="F1EFEA"/>
-          </a:solidFill>
-          <a:ln>
-            <a:noFill/>
-          </a:ln>
-          <a:effectLst/>
-        </p:spPr>
-        <p:style>
-          <a:lnRef idx="1">
-            <a:schemeClr val="accent1"/>
-          </a:lnRef>
-          <a:fillRef idx="3">
-            <a:schemeClr val="accent1"/>
-          </a:fillRef>
-          <a:effectRef idx="2">
-            <a:schemeClr val="accent1"/>
-          </a:effectRef>
-          <a:fontRef idx="minor">
-            <a:schemeClr val="lt1"/>
-          </a:fontRef>
-        </p:style>
-        <p:txBody>
-          <a:bodyPr rtlCol="0" anchor="ctr"/>
-          <a:lstStyle/>
-          <a:p>
-            <a:pPr algn="ctr"/>
+              <a:t>Montre-moi des baskets solides et pas chères pour marcher beaucoup</a:t>
+            </a:r>
+          </a:p>
+        </p:txBody>
+      </p:sp>
+      <p:sp>
+        <p:nvSpPr>
+          <p:cNvPr id="71" name="TextBox 70"/>
+          <p:cNvSpPr txBox="1"/>
+          <p:nvPr/>
+        </p:nvSpPr>
+        <p:spPr>
+          <a:xfrm>
+            <a:off x="8101584" y="3767328"/>
+            <a:ext cx="2926080" cy="152400"/>
+          </a:xfrm>
+          <a:prstGeom prst="rect">
+            <a:avLst/>
+          </a:prstGeom>
+          <a:noFill/>
+        </p:spPr>
+        <p:txBody>
+          <a:bodyPr wrap="square" anchor="t" lIns="0" rIns="0" tIns="0" bIns="0">
+            <a:spAutoFit/>
+          </a:bodyPr>
+          <a:lstStyle/>
+          <a:p>
+            <a:pPr algn="l"/>
+            <a:r>
+              <a:rPr sz="1300" b="1" i="0">
+                <a:solidFill>
+                  <a:srgbClr val="555B66"/>
+                </a:solidFill>
+                <a:latin typeface="Arial"/>
+              </a:rPr>
+              <a:t>CATÉGORIES DE PRODUITS</a:t>
+            </a:r>
           </a:p>
         </p:txBody>
       </p:sp>
@@ -5901,8 +5892,8 @@
         </p:nvSpPr>
         <p:spPr>
           <a:xfrm>
-            <a:off x="4559808" y="5364480"/>
-            <a:ext cx="182880" cy="304800"/>
+            <a:off x="8101584" y="3992880"/>
+            <a:ext cx="2926080" cy="121920"/>
           </a:xfrm>
           <a:prstGeom prst="rect">
             <a:avLst/>
@@ -5910,20 +5901,20 @@
           <a:noFill/>
         </p:spPr>
         <p:txBody>
-          <a:bodyPr wrap="square" anchor="ctr" lIns="0" rIns="0" tIns="0" bIns="0">
+          <a:bodyPr wrap="square" anchor="t" lIns="0" rIns="0" tIns="0" bIns="0">
             <a:spAutoFit/>
           </a:bodyPr>
           <a:lstStyle/>
           <a:p>
             <a:pPr algn="l"/>
             <a:r>
-              <a:rPr sz="900" b="0" i="0">
-                <a:solidFill>
-                  <a:srgbClr val="555B66"/>
-                </a:solidFill>
-                <a:latin typeface="Arial"/>
-              </a:rPr>
-              <a:t>🔍</a:t>
+              <a:rPr sz="1000" b="0" i="1">
+                <a:solidFill>
+                  <a:srgbClr val="8A93A6"/>
+                </a:solidFill>
+                <a:latin typeface="Arial"/>
+              </a:rPr>
+              <a:t>Répartition des requêtes</a:t>
             </a:r>
           </a:p>
         </p:txBody>
@@ -5936,157 +5927,8 @@
         </p:nvSpPr>
         <p:spPr>
           <a:xfrm>
-            <a:off x="4791456" y="5364480"/>
-            <a:ext cx="2499360" cy="304800"/>
-          </a:xfrm>
-          <a:prstGeom prst="rect">
-            <a:avLst/>
-          </a:prstGeom>
-          <a:noFill/>
-        </p:spPr>
-        <p:txBody>
-          <a:bodyPr wrap="square" anchor="ctr" lIns="0" rIns="0" tIns="0" bIns="0">
-            <a:spAutoFit/>
-          </a:bodyPr>
-          <a:lstStyle/>
-          <a:p>
-            <a:pPr algn="l"/>
-            <a:r>
-              <a:rPr sz="900" b="0" i="0">
-                <a:solidFill>
-                  <a:srgbClr val="111111"/>
-                </a:solidFill>
-                <a:latin typeface="Arial"/>
-              </a:rPr>
-              <a:t>Quels types de lacets aident les sneakers à mieux s'ajuster ?</a:t>
-            </a:r>
-          </a:p>
-        </p:txBody>
-      </p:sp>
-      <p:sp>
-        <p:nvSpPr>
-          <p:cNvPr id="74" name="Rectangle 73"/>
-          <p:cNvSpPr/>
-          <p:nvPr/>
-        </p:nvSpPr>
-        <p:spPr>
-          <a:xfrm>
-            <a:off x="4437888" y="5730240"/>
-            <a:ext cx="2913888" cy="304800"/>
-          </a:xfrm>
-          <a:prstGeom prst="rect">
-            <a:avLst/>
-          </a:prstGeom>
-          <a:solidFill>
-            <a:srgbClr val="F1EFEA"/>
-          </a:solidFill>
-          <a:ln>
-            <a:noFill/>
-          </a:ln>
-          <a:effectLst/>
-        </p:spPr>
-        <p:style>
-          <a:lnRef idx="1">
-            <a:schemeClr val="accent1"/>
-          </a:lnRef>
-          <a:fillRef idx="3">
-            <a:schemeClr val="accent1"/>
-          </a:fillRef>
-          <a:effectRef idx="2">
-            <a:schemeClr val="accent1"/>
-          </a:effectRef>
-          <a:fontRef idx="minor">
-            <a:schemeClr val="lt1"/>
-          </a:fontRef>
-        </p:style>
-        <p:txBody>
-          <a:bodyPr rtlCol="0" anchor="ctr"/>
-          <a:lstStyle/>
-          <a:p>
-            <a:pPr algn="ctr"/>
-          </a:p>
-        </p:txBody>
-      </p:sp>
-      <p:sp>
-        <p:nvSpPr>
-          <p:cNvPr id="75" name="TextBox 74"/>
-          <p:cNvSpPr txBox="1"/>
-          <p:nvPr/>
-        </p:nvSpPr>
-        <p:spPr>
-          <a:xfrm>
-            <a:off x="4559808" y="5730240"/>
-            <a:ext cx="182880" cy="304800"/>
-          </a:xfrm>
-          <a:prstGeom prst="rect">
-            <a:avLst/>
-          </a:prstGeom>
-          <a:noFill/>
-        </p:spPr>
-        <p:txBody>
-          <a:bodyPr wrap="square" anchor="ctr" lIns="0" rIns="0" tIns="0" bIns="0">
-            <a:spAutoFit/>
-          </a:bodyPr>
-          <a:lstStyle/>
-          <a:p>
-            <a:pPr algn="l"/>
-            <a:r>
-              <a:rPr sz="900" b="0" i="0">
-                <a:solidFill>
-                  <a:srgbClr val="555B66"/>
-                </a:solidFill>
-                <a:latin typeface="Arial"/>
-              </a:rPr>
-              <a:t>🔍</a:t>
-            </a:r>
-          </a:p>
-        </p:txBody>
-      </p:sp>
-      <p:sp>
-        <p:nvSpPr>
-          <p:cNvPr id="76" name="TextBox 75"/>
-          <p:cNvSpPr txBox="1"/>
-          <p:nvPr/>
-        </p:nvSpPr>
-        <p:spPr>
-          <a:xfrm>
-            <a:off x="4791456" y="5730240"/>
-            <a:ext cx="2499360" cy="304800"/>
-          </a:xfrm>
-          <a:prstGeom prst="rect">
-            <a:avLst/>
-          </a:prstGeom>
-          <a:noFill/>
-        </p:spPr>
-        <p:txBody>
-          <a:bodyPr wrap="square" anchor="ctr" lIns="0" rIns="0" tIns="0" bIns="0">
-            <a:spAutoFit/>
-          </a:bodyPr>
-          <a:lstStyle/>
-          <a:p>
-            <a:pPr algn="l"/>
-            <a:r>
-              <a:rPr sz="900" b="0" i="0">
-                <a:solidFill>
-                  <a:srgbClr val="111111"/>
-                </a:solidFill>
-                <a:latin typeface="Arial"/>
-              </a:rPr>
-              <a:t>Je peux utiliser le Wilson Authentic en salle sans l'abîmer ?</a:t>
-            </a:r>
-          </a:p>
-        </p:txBody>
-      </p:sp>
-      <p:sp>
-        <p:nvSpPr>
-          <p:cNvPr id="77" name="TextBox 76"/>
-          <p:cNvSpPr txBox="1"/>
-          <p:nvPr/>
-        </p:nvSpPr>
-        <p:spPr>
-          <a:xfrm>
-            <a:off x="8101584" y="3767328"/>
-            <a:ext cx="2926080" cy="152400"/>
+            <a:off x="10607040" y="4175760"/>
+            <a:ext cx="518160" cy="121920"/>
           </a:xfrm>
           <a:prstGeom prst="rect">
             <a:avLst/>
@@ -6099,76 +5941,6 @@
           </a:bodyPr>
           <a:lstStyle/>
           <a:p>
-            <a:pPr algn="l"/>
-            <a:r>
-              <a:rPr sz="1300" b="1" i="0">
-                <a:solidFill>
-                  <a:srgbClr val="555B66"/>
-                </a:solidFill>
-                <a:latin typeface="Arial"/>
-              </a:rPr>
-              <a:t>CATÉGORIES DE PRODUITS</a:t>
-            </a:r>
-          </a:p>
-        </p:txBody>
-      </p:sp>
-      <p:sp>
-        <p:nvSpPr>
-          <p:cNvPr id="78" name="TextBox 77"/>
-          <p:cNvSpPr txBox="1"/>
-          <p:nvPr/>
-        </p:nvSpPr>
-        <p:spPr>
-          <a:xfrm>
-            <a:off x="8101584" y="3992880"/>
-            <a:ext cx="2926080" cy="121920"/>
-          </a:xfrm>
-          <a:prstGeom prst="rect">
-            <a:avLst/>
-          </a:prstGeom>
-          <a:noFill/>
-        </p:spPr>
-        <p:txBody>
-          <a:bodyPr wrap="square" anchor="t" lIns="0" rIns="0" tIns="0" bIns="0">
-            <a:spAutoFit/>
-          </a:bodyPr>
-          <a:lstStyle/>
-          <a:p>
-            <a:pPr algn="l"/>
-            <a:r>
-              <a:rPr sz="1000" b="0" i="1">
-                <a:solidFill>
-                  <a:srgbClr val="8A93A6"/>
-                </a:solidFill>
-                <a:latin typeface="Arial"/>
-              </a:rPr>
-              <a:t>Répartition des requêtes</a:t>
-            </a:r>
-          </a:p>
-        </p:txBody>
-      </p:sp>
-      <p:sp>
-        <p:nvSpPr>
-          <p:cNvPr id="79" name="TextBox 78"/>
-          <p:cNvSpPr txBox="1"/>
-          <p:nvPr/>
-        </p:nvSpPr>
-        <p:spPr>
-          <a:xfrm>
-            <a:off x="10607040" y="4175760"/>
-            <a:ext cx="518160" cy="121920"/>
-          </a:xfrm>
-          <a:prstGeom prst="rect">
-            <a:avLst/>
-          </a:prstGeom>
-          <a:noFill/>
-        </p:spPr>
-        <p:txBody>
-          <a:bodyPr wrap="square" anchor="t" lIns="0" rIns="0" tIns="0" bIns="0">
-            <a:spAutoFit/>
-          </a:bodyPr>
-          <a:lstStyle/>
-          <a:p>
             <a:pPr algn="r"/>
             <a:r>
               <a:rPr sz="1100" b="1" i="0">
@@ -6184,7 +5956,7 @@
       </p:sp>
       <p:sp>
         <p:nvSpPr>
-          <p:cNvPr id="80" name="Rectangle 79"/>
+          <p:cNvPr id="74" name="Rectangle 73"/>
           <p:cNvSpPr/>
           <p:nvPr/>
         </p:nvSpPr>
@@ -6228,7 +6000,7 @@
       </p:sp>
       <p:sp>
         <p:nvSpPr>
-          <p:cNvPr id="81" name="TextBox 80"/>
+          <p:cNvPr id="75" name="TextBox 74"/>
           <p:cNvSpPr txBox="1"/>
           <p:nvPr/>
         </p:nvSpPr>
@@ -6263,7 +6035,7 @@
       </p:sp>
       <p:sp>
         <p:nvSpPr>
-          <p:cNvPr id="82" name="Rectangle 81"/>
+          <p:cNvPr id="76" name="Rectangle 75"/>
           <p:cNvSpPr/>
           <p:nvPr/>
         </p:nvSpPr>
@@ -6307,7 +6079,7 @@
       </p:sp>
       <p:sp>
         <p:nvSpPr>
-          <p:cNvPr id="83" name="TextBox 82"/>
+          <p:cNvPr id="77" name="TextBox 76"/>
           <p:cNvSpPr txBox="1"/>
           <p:nvPr/>
         </p:nvSpPr>
@@ -6342,7 +6114,7 @@
       </p:sp>
       <p:sp>
         <p:nvSpPr>
-          <p:cNvPr id="84" name="Rectangle 83"/>
+          <p:cNvPr id="78" name="Rectangle 77"/>
           <p:cNvSpPr/>
           <p:nvPr/>
         </p:nvSpPr>
@@ -6386,7 +6158,7 @@
       </p:sp>
       <p:sp>
         <p:nvSpPr>
-          <p:cNvPr id="85" name="TextBox 84"/>
+          <p:cNvPr id="79" name="TextBox 78"/>
           <p:cNvSpPr txBox="1"/>
           <p:nvPr/>
         </p:nvSpPr>
@@ -6421,7 +6193,7 @@
       </p:sp>
       <p:sp>
         <p:nvSpPr>
-          <p:cNvPr id="86" name="Rectangle 85"/>
+          <p:cNvPr id="80" name="Rectangle 79"/>
           <p:cNvSpPr/>
           <p:nvPr/>
         </p:nvSpPr>
@@ -6465,7 +6237,7 @@
       </p:sp>
       <p:sp>
         <p:nvSpPr>
-          <p:cNvPr id="87" name="TextBox 86"/>
+          <p:cNvPr id="81" name="TextBox 80"/>
           <p:cNvSpPr txBox="1"/>
           <p:nvPr/>
         </p:nvSpPr>
@@ -6500,7 +6272,7 @@
       </p:sp>
       <p:sp>
         <p:nvSpPr>
-          <p:cNvPr id="88" name="Rectangle 87"/>
+          <p:cNvPr id="82" name="Rectangle 81"/>
           <p:cNvSpPr/>
           <p:nvPr/>
         </p:nvSpPr>
@@ -6544,7 +6316,7 @@
       </p:sp>
       <p:sp>
         <p:nvSpPr>
-          <p:cNvPr id="89" name="Rectangle 88"/>
+          <p:cNvPr id="83" name="Rectangle 82"/>
           <p:cNvSpPr/>
           <p:nvPr/>
         </p:nvSpPr>
@@ -6588,7 +6360,7 @@
       </p:sp>
       <p:sp>
         <p:nvSpPr>
-          <p:cNvPr id="90" name="TextBox 89"/>
+          <p:cNvPr id="84" name="TextBox 83"/>
           <p:cNvSpPr txBox="1"/>
           <p:nvPr/>
         </p:nvSpPr>
@@ -6623,7 +6395,7 @@
       </p:sp>
       <p:sp>
         <p:nvSpPr>
-          <p:cNvPr id="91" name="Rectangle 90"/>
+          <p:cNvPr id="85" name="Rectangle 84"/>
           <p:cNvSpPr/>
           <p:nvPr/>
         </p:nvSpPr>
@@ -6667,7 +6439,7 @@
       </p:sp>
       <p:sp>
         <p:nvSpPr>
-          <p:cNvPr id="92" name="Rectangle 91"/>
+          <p:cNvPr id="86" name="Rectangle 85"/>
           <p:cNvSpPr/>
           <p:nvPr/>
         </p:nvSpPr>
@@ -6711,7 +6483,7 @@
       </p:sp>
       <p:sp>
         <p:nvSpPr>
-          <p:cNvPr id="93" name="TextBox 92"/>
+          <p:cNvPr id="87" name="TextBox 86"/>
           <p:cNvSpPr txBox="1"/>
           <p:nvPr/>
         </p:nvSpPr>
@@ -7331,7 +7103,7 @@
                 </a:solidFill>
                 <a:latin typeface="Arial"/>
               </a:rPr>
-              <a:t>Revoir les annonces vêtements et maillots</a:t>
+              <a:t>Renvoyer vers des fiches produit plutôt que des pages catégorie</a:t>
             </a:r>
           </a:p>
         </p:txBody>
@@ -7366,7 +7138,7 @@
                 </a:solidFill>
                 <a:latin typeface="Arial"/>
               </a:rPr>
-              <a:t>Les tenues de basket restent à 0,58 fois la moyenne et les maillots à 0,82 fois. Les survêtements et les casquettes tombent à 0,41 fois.</a:t>
+              <a:t>Les annonces qui renvoient vers une fiche produit atteignent 1,06 fois le CTR moyen, contre 0,86 fois pour celles qui renvoient vers une page catégorie (survêtements, casquettes, maillots Paris Basketball).</a:t>
             </a:r>
           </a:p>
         </p:txBody>
@@ -7401,7 +7173,7 @@
                 </a:solidFill>
                 <a:latin typeface="Arial"/>
               </a:rPr>
-              <a:t>→  Associer les vêtements à un usage (match, échauffement, cadeau) plutôt qu'au prix.</a:t>
+              <a:t>→  Remplacer les annonces catégorie par des produits précis du flux.</a:t>
             </a:r>
           </a:p>
         </p:txBody>

</xml_diff>